<commit_message>
feat: improve phase 1 docs and metrics
</commit_message>
<xml_diff>
--- a/docs/presentation/fraudlens-bharat-phase-1-pitch.pptx
+++ b/docs/presentation/fraudlens-bharat-phase-1-pitch.pptx
@@ -2397,7 +2397,7 @@
                 <a:ea typeface="Aptos"/>
                 <a:cs typeface="Aptos"/>
               </a:rPr>
-              <a:t>0.875</a:t>
+              <a:t>1.0000</a:t>
             </a:r>
           </a:p>
         </p:txBody>
@@ -2525,7 +2525,7 @@
                 <a:ea typeface="Aptos"/>
                 <a:cs typeface="Aptos"/>
               </a:rPr>
-              <a:t>baseline on seed evaluation split</a:t>
+              <a:t>hybrid baseline on synthetic split</a:t>
             </a:r>
           </a:p>
         </p:txBody>
@@ -2657,7 +2657,7 @@
                 <a:ea typeface="Aptos"/>
                 <a:cs typeface="Aptos"/>
               </a:rPr>
-              <a:t>12</a:t>
+              <a:t>15</a:t>
             </a:r>
           </a:p>
         </p:txBody>
@@ -15102,7 +15102,7 @@
                 <a:ea typeface="Aptos"/>
                 <a:cs typeface="Aptos"/>
               </a:rPr>
-              <a:t>0.875</a:t>
+              <a:t>1.0000</a:t>
             </a:r>
           </a:p>
         </p:txBody>
@@ -15298,7 +15298,7 @@
                 <a:ea typeface="Aptos"/>
                 <a:cs typeface="Aptos"/>
               </a:rPr>
-              <a:t>0.875</a:t>
+              <a:t>1.0000</a:t>
             </a:r>
           </a:p>
         </p:txBody>
@@ -16478,7 +16478,7 @@
                 <a:ea typeface="Aptos"/>
                 <a:cs typeface="Aptos"/>
               </a:rPr>
-              <a:t>courier / digital arrest</a:t>
+              <a:t>courier_scam</a:t>
             </a:r>
           </a:p>
         </p:txBody>
@@ -16612,7 +16612,7 @@
                 <a:ea typeface="Aptos"/>
                 <a:cs typeface="Aptos"/>
               </a:rPr>
-              <a:t>0.500</a:t>
+              <a:t>1.000</a:t>
             </a:r>
           </a:p>
         </p:txBody>
@@ -16795,7 +16795,7 @@
                 <a:ea typeface="Aptos"/>
                 <a:cs typeface="Aptos"/>
               </a:rPr>
-              <a:t>Interpretation: strong early baseline, with known confusion between courier-scam and digital-arrest language. That becomes a Phase 2 improvement target.</a:t>
+              <a:t>Interpretation: synthetic split is clean after marker fixes; treat as internal Phase 1 evidence, not production accuracy.</a:t>
             </a:r>
           </a:p>
         </p:txBody>

</xml_diff>